<commit_message>
link added to presentation
</commit_message>
<xml_diff>
--- a/Musonda Sinkala - Technical Interview - Ghamut.pptx
+++ b/Musonda Sinkala - Technical Interview - Ghamut.pptx
@@ -10184,14 +10184,29 @@
             <a:r>
               <a:rPr lang="en-US" sz="4000" kern="1200" dirty="0">
                 <a:solidFill>
-                  <a:srgbClr val="FFFFFF"/>
+                  <a:schemeClr val="bg1"/>
                 </a:solidFill>
                 <a:latin typeface="+mj-lt"/>
                 <a:ea typeface="+mj-ea"/>
                 <a:cs typeface="+mj-cs"/>
+                <a:hlinkClick r:id="rId7">
+                  <a:extLst>
+                    <a:ext uri="{A12FA001-AC4F-418D-AE19-62706E023703}">
+                      <ahyp:hlinkClr xmlns:ahyp="http://schemas.microsoft.com/office/drawing/2018/hyperlinkcolor" val="tx"/>
+                    </a:ext>
+                  </a:extLst>
+                </a:hlinkClick>
               </a:rPr>
               <a:t>Insights</a:t>
             </a:r>
+            <a:endParaRPr lang="en-US" sz="4000" kern="1200" dirty="0">
+              <a:solidFill>
+                <a:schemeClr val="bg1"/>
+              </a:solidFill>
+              <a:latin typeface="+mj-lt"/>
+              <a:ea typeface="+mj-ea"/>
+              <a:cs typeface="+mj-cs"/>
+            </a:endParaRPr>
           </a:p>
         </p:txBody>
       </p:sp>

</xml_diff>